<commit_message>
Refine projected maps and add top10 barline variants
</commit_message>
<xml_diff>
--- a/tasks/bird_spatiotemporal_patterns/figures/fig_sp01_province_new_record_count_map.pptx
+++ b/tasks/bird_spatiotemporal_patterns/figures/fig_sp01_province_new_record_count_map.pptx
@@ -2234,6 +2234,32 @@
           <a:xfrm>
             <a:off x="0" y="0"/>
             <a:ext cx="9144000" cy="6858000"/>
+          </a:xfrm>
+          <a:prstGeom prst="rect">
+            <a:avLst/>
+          </a:prstGeom>
+        </p:spPr>
+      </p:pic>
+      <p:pic>
+        <p:nvPicPr>
+          <p:cNvPr id="3" name="" descr=""/>
+          <p:cNvPicPr>
+            <a:picLocks noGrp="1"/>
+          </p:cNvPicPr>
+          <p:nvPr>
+            <p:ph/>
+          </p:nvPr>
+        </p:nvPicPr>
+        <p:blipFill>
+          <a:blip r:embed="rId3"/>
+          <a:stretch>
+            <a:fillRect/>
+          </a:stretch>
+        </p:blipFill>
+        <p:spPr>
+          <a:xfrm>
+            <a:off x="7315200" y="4732020"/>
+            <a:ext cx="1783080" cy="1988820"/>
           </a:xfrm>
           <a:prstGeom prst="rect">
             <a:avLst/>

</xml_diff>

<commit_message>
Refine bird map layout and diagnostics
</commit_message>
<xml_diff>
--- a/tasks/bird_spatiotemporal_patterns/figures/fig_sp01_province_new_record_count_map.pptx
+++ b/tasks/bird_spatiotemporal_patterns/figures/fig_sp01_province_new_record_count_map.pptx
@@ -2258,8 +2258,8 @@
         </p:blipFill>
         <p:spPr>
           <a:xfrm>
-            <a:off x="7315200" y="4732020"/>
-            <a:ext cx="1783080" cy="1988820"/>
+            <a:off x="7543800" y="5225796"/>
+            <a:ext cx="1554480" cy="1611630"/>
           </a:xfrm>
           <a:prstGeom prst="rect">
             <a:avLst/>

</xml_diff>

<commit_message>
Recenter bird maps and add graticules
</commit_message>
<xml_diff>
--- a/tasks/bird_spatiotemporal_patterns/figures/fig_sp01_province_new_record_count_map.pptx
+++ b/tasks/bird_spatiotemporal_patterns/figures/fig_sp01_province_new_record_count_map.pptx
@@ -2258,8 +2258,8 @@
         </p:blipFill>
         <p:spPr>
           <a:xfrm>
-            <a:off x="7543800" y="5225796"/>
-            <a:ext cx="1554480" cy="1611630"/>
+            <a:off x="7818120" y="5362956"/>
+            <a:ext cx="1307592" cy="1488186"/>
           </a:xfrm>
           <a:prstGeom prst="rect">
             <a:avLst/>

</xml_diff>

<commit_message>
Tune legend and inset placement
</commit_message>
<xml_diff>
--- a/tasks/bird_spatiotemporal_patterns/figures/fig_sp01_province_new_record_count_map.pptx
+++ b/tasks/bird_spatiotemporal_patterns/figures/fig_sp01_province_new_record_count_map.pptx
@@ -2258,8 +2258,8 @@
         </p:blipFill>
         <p:spPr>
           <a:xfrm>
-            <a:off x="7818120" y="5362956"/>
-            <a:ext cx="1307592" cy="1488186"/>
+            <a:off x="7699248" y="5266944"/>
+            <a:ext cx="1426464" cy="1587627"/>
           </a:xfrm>
           <a:prstGeom prst="rect">
             <a:avLst/>

</xml_diff>